<commit_message>
Fix JARVIS chat switching and simplify workspace
</commit_message>
<xml_diff>
--- a/JARVIS/outputs/presentation/JARVIS_FINAL_DEFENSE_UK.pptx
+++ b/JARVIS/outputs/presentation/JARVIS_FINAL_DEFENSE_UK.pptx
@@ -2,22 +2,22 @@
 <file path=ppt/presentation.xml><?xml version="1.0" encoding="utf-8"?>
 <p:presentation xmlns:p="http://schemas.openxmlformats.org/presentationml/2006/main">
   <p:sldMasterIdLst>
-    <p:sldMasterId xmlns:r="http://schemas.openxmlformats.org/officeDocument/2006/relationships" id="2147483648" r:id="R6f9a260fae644b23"/>
+    <p:sldMasterId xmlns:r="http://schemas.openxmlformats.org/officeDocument/2006/relationships" id="2147483648" r:id="R4c4622a48d364a09"/>
   </p:sldMasterIdLst>
   <p:notesMasterIdLst>
-    <p:notesMasterId xmlns:r="http://schemas.openxmlformats.org/officeDocument/2006/relationships" r:id="R3618c9028fce46dc"/>
+    <p:notesMasterId xmlns:r="http://schemas.openxmlformats.org/officeDocument/2006/relationships" r:id="Ra3e891d42a4140ff"/>
   </p:notesMasterIdLst>
   <p:sldIdLst>
-    <p:sldId xmlns:r="http://schemas.openxmlformats.org/officeDocument/2006/relationships" id="256" r:id="Rd3ff6682a8494343"/>
-    <p:sldId xmlns:r="http://schemas.openxmlformats.org/officeDocument/2006/relationships" id="257" r:id="R6a86437bf8fe4fcd"/>
-    <p:sldId xmlns:r="http://schemas.openxmlformats.org/officeDocument/2006/relationships" id="258" r:id="R87414cd3fc544d9a"/>
-    <p:sldId xmlns:r="http://schemas.openxmlformats.org/officeDocument/2006/relationships" id="259" r:id="R8514393237a24155"/>
-    <p:sldId xmlns:r="http://schemas.openxmlformats.org/officeDocument/2006/relationships" id="260" r:id="R1b9f63197f0c41d2"/>
-    <p:sldId xmlns:r="http://schemas.openxmlformats.org/officeDocument/2006/relationships" id="261" r:id="Rc130f984b35d4442"/>
-    <p:sldId xmlns:r="http://schemas.openxmlformats.org/officeDocument/2006/relationships" id="262" r:id="R2dea994c72c24c4e"/>
-    <p:sldId xmlns:r="http://schemas.openxmlformats.org/officeDocument/2006/relationships" id="263" r:id="R8ea04bbe65364952"/>
-    <p:sldId xmlns:r="http://schemas.openxmlformats.org/officeDocument/2006/relationships" id="264" r:id="R8f97a6d2151f4aa2"/>
-    <p:sldId xmlns:r="http://schemas.openxmlformats.org/officeDocument/2006/relationships" id="265" r:id="R3bb41b8520514a2e"/>
+    <p:sldId xmlns:r="http://schemas.openxmlformats.org/officeDocument/2006/relationships" id="256" r:id="R8e9e9223779a4efc"/>
+    <p:sldId xmlns:r="http://schemas.openxmlformats.org/officeDocument/2006/relationships" id="257" r:id="Ra5d0f0fb7eaa48d6"/>
+    <p:sldId xmlns:r="http://schemas.openxmlformats.org/officeDocument/2006/relationships" id="258" r:id="Ra0fdfbe7002f40bd"/>
+    <p:sldId xmlns:r="http://schemas.openxmlformats.org/officeDocument/2006/relationships" id="259" r:id="R596686c1b8474605"/>
+    <p:sldId xmlns:r="http://schemas.openxmlformats.org/officeDocument/2006/relationships" id="260" r:id="R7aec111bb33e4998"/>
+    <p:sldId xmlns:r="http://schemas.openxmlformats.org/officeDocument/2006/relationships" id="261" r:id="Rc0703607129542ab"/>
+    <p:sldId xmlns:r="http://schemas.openxmlformats.org/officeDocument/2006/relationships" id="262" r:id="R23578347d8b849d2"/>
+    <p:sldId xmlns:r="http://schemas.openxmlformats.org/officeDocument/2006/relationships" id="263" r:id="Rb2720b43d87841f8"/>
+    <p:sldId xmlns:r="http://schemas.openxmlformats.org/officeDocument/2006/relationships" id="264" r:id="R2d470eedbcff486c"/>
+    <p:sldId xmlns:r="http://schemas.openxmlformats.org/officeDocument/2006/relationships" id="265" r:id="R73e14a4ee4844695"/>
   </p:sldIdLst>
   <p:sldSz cx="12192000" cy="6858000"/>
   <p:notesSz cx="6858000" cy="9144000"/>
@@ -1236,7 +1236,7 @@
           <a:lstStyle xmlns:a="http://schemas.openxmlformats.org/drawingml/2006/main"/>
           <a:p xmlns:a="http://schemas.openxmlformats.org/drawingml/2006/main">
             <a:r>
-              <a:t>У desktop проєкти — це розкривні папки, а chats вкладені під ними. Однаковий абсолютний шлях не дублюється. Conversations можна перейменувати, архівувати та відновити; справа видно corpus і preview, знизу dependency graph.</a:t>
+              <a:t>У desktop проєкти — це розкривні папки, а chats вкладені під ними. Перемикання очищає попередній стан і захищене від запізнілих відповідей backend. Однаковий абсолютний шлях не дублюється. Conversations можна перейменувати, архівувати та відновити. Робоча область повністю віддана чату, а corpus обирається у верхньому selector.</a:t>
             </a:r>
           </a:p>
           <a:p xmlns:a="http://schemas.openxmlformats.org/drawingml/2006/main">
@@ -1331,7 +1331,7 @@
           <a:lstStyle xmlns:a="http://schemas.openxmlformats.org/drawingml/2006/main"/>
           <a:p xmlns:a="http://schemas.openxmlformats.org/drawingml/2006/main">
             <a:r>
-              <a:t>Перевірка не обмежується скриншотом: 41 test passed. Live sync проєкту Сашен сайт дав 975 current chunks, 975 document mappings і нуль локальних текстових chunks. EXE, MSI та NSIS зібрані на Python 3.12 runtime.</a:t>
+              <a:t>Перевірка не обмежується скриншотом: 44 tests passed. Live sync проєкту Сашен сайт дав 975 current chunks, 975 document mappings і нуль локальних текстових chunks. EXE, MSI та NSIS зібрані на Python 3.12 runtime.</a:t>
             </a:r>
           </a:p>
           <a:p xmlns:a="http://schemas.openxmlformats.org/drawingml/2006/main">
@@ -1352,6 +1352,11 @@
           <a:p xmlns:a="http://schemas.openxmlformats.org/drawingml/2006/main">
             <a:r>
               <a:t>- C:/Все мои проэкты/rag-homework/JARVIS/tests/test_desktop_rag.py</a:t>
+            </a:r>
+          </a:p>
+          <a:p xmlns:a="http://schemas.openxmlformats.org/drawingml/2006/main">
+            <a:r>
+              <a:t>- C:/Все мои проэкты/rag-homework/JARVIS/tests/test_desktop_source_contract.py</a:t>
             </a:r>
           </a:p>
           <a:p xmlns:a="http://schemas.openxmlformats.org/drawingml/2006/main">
@@ -1429,7 +1434,7 @@
   </p:cSld>
   <p:clrMap bg1="lt1" tx1="dk1" bg2="lt2" tx2="dk2" accent1="accent1" accent2="accent2" accent3="accent3" accent4="accent4" accent5="accent5" accent6="accent6" hlink="hlink" folHlink="folHlink"/>
   <p:sldLayoutIdLst>
-    <p:sldLayoutId xmlns:r="http://schemas.openxmlformats.org/officeDocument/2006/relationships" id="2147483649" r:id="R22a5139d693d4b53"/>
+    <p:sldLayoutId xmlns:r="http://schemas.openxmlformats.org/officeDocument/2006/relationships" id="2147483649" r:id="R488c00a4a0ef4710"/>
   </p:sldLayoutIdLst>
   <p:txStyles>
     <p:titleStyle>
@@ -2042,6 +2047,7 @@
           <a:lstStyle xmlns:a="http://schemas.openxmlformats.org/drawingml/2006/main"/>
           <a:p xmlns:a="http://schemas.openxmlformats.org/drawingml/2006/main">
             <a:pPr algn="l">
+              <a:buNone/>
               <a:defRPr sz="5400" b="1">
                 <a:solidFill>
                   <a:srgbClr val="FFFFFF"/>
@@ -2094,6 +2100,7 @@
           <a:lstStyle xmlns:a="http://schemas.openxmlformats.org/drawingml/2006/main"/>
           <a:p xmlns:a="http://schemas.openxmlformats.org/drawingml/2006/main">
             <a:pPr algn="l">
+              <a:buNone/>
               <a:defRPr sz="2325" b="0">
                 <a:solidFill>
                   <a:srgbClr val="D0D5DD"/>
@@ -2111,6 +2118,7 @@
           </a:p>
           <a:p xmlns:a="http://schemas.openxmlformats.org/drawingml/2006/main">
             <a:pPr algn="l">
+              <a:buNone/>
               <a:defRPr sz="2325" b="0">
                 <a:solidFill>
                   <a:srgbClr val="D0D5DD"/>
@@ -2163,6 +2171,7 @@
           <a:lstStyle xmlns:a="http://schemas.openxmlformats.org/drawingml/2006/main"/>
           <a:p xmlns:a="http://schemas.openxmlformats.org/drawingml/2006/main">
             <a:pPr algn="l">
+              <a:buNone/>
               <a:defRPr sz="1275" b="1">
                 <a:solidFill>
                   <a:srgbClr val="84ADFF"/>
@@ -2247,6 +2256,7 @@
           <a:lstStyle xmlns:a="http://schemas.openxmlformats.org/drawingml/2006/main"/>
           <a:p xmlns:a="http://schemas.openxmlformats.org/drawingml/2006/main">
             <a:pPr algn="l">
+              <a:buNone/>
               <a:defRPr sz="1275" b="0">
                 <a:solidFill>
                   <a:srgbClr val="98A2B3"/>
@@ -2334,6 +2344,7 @@
           <a:lstStyle xmlns:a="http://schemas.openxmlformats.org/drawingml/2006/main"/>
           <a:p xmlns:a="http://schemas.openxmlformats.org/drawingml/2006/main">
             <a:pPr algn="ctr">
+              <a:buNone/>
               <a:defRPr sz="6450" b="1">
                 <a:solidFill>
                   <a:srgbClr val="84ADFF"/>
@@ -2386,6 +2397,7 @@
           <a:lstStyle xmlns:a="http://schemas.openxmlformats.org/drawingml/2006/main"/>
           <a:p xmlns:a="http://schemas.openxmlformats.org/drawingml/2006/main">
             <a:pPr algn="ctr">
+              <a:buNone/>
               <a:defRPr sz="1050" b="1">
                 <a:solidFill>
                   <a:srgbClr val="98A2B3"/>
@@ -2438,6 +2450,7 @@
           <a:lstStyle xmlns:a="http://schemas.openxmlformats.org/drawingml/2006/main"/>
           <a:p xmlns:a="http://schemas.openxmlformats.org/drawingml/2006/main">
             <a:pPr algn="l">
+              <a:buNone/>
               <a:defRPr sz="1350" b="0">
                 <a:solidFill>
                   <a:srgbClr val="D0D5DD"/>
@@ -2490,6 +2503,7 @@
           <a:lstStyle xmlns:a="http://schemas.openxmlformats.org/drawingml/2006/main"/>
           <a:p xmlns:a="http://schemas.openxmlformats.org/drawingml/2006/main">
             <a:pPr algn="r">
+              <a:buNone/>
               <a:defRPr sz="975" b="1">
                 <a:solidFill>
                   <a:srgbClr val="667085"/>
@@ -2603,6 +2617,7 @@
           <a:lstStyle xmlns:a="http://schemas.openxmlformats.org/drawingml/2006/main"/>
           <a:p xmlns:a="http://schemas.openxmlformats.org/drawingml/2006/main">
             <a:pPr algn="l">
+              <a:buNone/>
               <a:defRPr sz="975" b="1">
                 <a:solidFill>
                   <a:srgbClr val="2F80ED"/>
@@ -2655,6 +2670,7 @@
           <a:lstStyle xmlns:a="http://schemas.openxmlformats.org/drawingml/2006/main"/>
           <a:p xmlns:a="http://schemas.openxmlformats.org/drawingml/2006/main">
             <a:pPr algn="l">
+              <a:buNone/>
               <a:defRPr sz="2850" b="1">
                 <a:solidFill>
                   <a:srgbClr val="101828"/>
@@ -2707,6 +2723,7 @@
           <a:lstStyle xmlns:a="http://schemas.openxmlformats.org/drawingml/2006/main"/>
           <a:p xmlns:a="http://schemas.openxmlformats.org/drawingml/2006/main">
             <a:pPr algn="r">
+              <a:buNone/>
               <a:defRPr sz="975" b="1">
                 <a:solidFill>
                   <a:srgbClr val="98A2B3"/>
@@ -2759,6 +2776,7 @@
           <a:lstStyle xmlns:a="http://schemas.openxmlformats.org/drawingml/2006/main"/>
           <a:p xmlns:a="http://schemas.openxmlformats.org/drawingml/2006/main">
             <a:pPr algn="l">
+              <a:buNone/>
               <a:defRPr sz="1425" b="1">
                 <a:solidFill>
                   <a:srgbClr val="2F80ED"/>
@@ -2811,6 +2829,7 @@
           <a:lstStyle xmlns:a="http://schemas.openxmlformats.org/drawingml/2006/main"/>
           <a:p xmlns:a="http://schemas.openxmlformats.org/drawingml/2006/main">
             <a:pPr algn="l">
+              <a:buNone/>
               <a:defRPr sz="2025" b="1">
                 <a:solidFill>
                   <a:srgbClr val="101828"/>
@@ -2863,6 +2882,7 @@
           <a:lstStyle xmlns:a="http://schemas.openxmlformats.org/drawingml/2006/main"/>
           <a:p xmlns:a="http://schemas.openxmlformats.org/drawingml/2006/main">
             <a:pPr algn="l">
+              <a:buNone/>
               <a:defRPr sz="1350" b="0">
                 <a:solidFill>
                   <a:srgbClr val="344054"/>
@@ -2915,6 +2935,7 @@
           <a:lstStyle xmlns:a="http://schemas.openxmlformats.org/drawingml/2006/main"/>
           <a:p xmlns:a="http://schemas.openxmlformats.org/drawingml/2006/main">
             <a:pPr algn="l">
+              <a:buNone/>
               <a:defRPr sz="1425" b="1">
                 <a:solidFill>
                   <a:srgbClr val="2F80ED"/>
@@ -2967,6 +2988,7 @@
           <a:lstStyle xmlns:a="http://schemas.openxmlformats.org/drawingml/2006/main"/>
           <a:p xmlns:a="http://schemas.openxmlformats.org/drawingml/2006/main">
             <a:pPr algn="l">
+              <a:buNone/>
               <a:defRPr sz="2025" b="1">
                 <a:solidFill>
                   <a:srgbClr val="101828"/>
@@ -3019,6 +3041,7 @@
           <a:lstStyle xmlns:a="http://schemas.openxmlformats.org/drawingml/2006/main"/>
           <a:p xmlns:a="http://schemas.openxmlformats.org/drawingml/2006/main">
             <a:pPr algn="l">
+              <a:buNone/>
               <a:defRPr sz="1350" b="0">
                 <a:solidFill>
                   <a:srgbClr val="344054"/>
@@ -3071,6 +3094,7 @@
           <a:lstStyle xmlns:a="http://schemas.openxmlformats.org/drawingml/2006/main"/>
           <a:p xmlns:a="http://schemas.openxmlformats.org/drawingml/2006/main">
             <a:pPr algn="l">
+              <a:buNone/>
               <a:defRPr sz="1425" b="1">
                 <a:solidFill>
                   <a:srgbClr val="2F80ED"/>
@@ -3123,6 +3147,7 @@
           <a:lstStyle xmlns:a="http://schemas.openxmlformats.org/drawingml/2006/main"/>
           <a:p xmlns:a="http://schemas.openxmlformats.org/drawingml/2006/main">
             <a:pPr algn="l">
+              <a:buNone/>
               <a:defRPr sz="2025" b="1">
                 <a:solidFill>
                   <a:srgbClr val="101828"/>
@@ -3175,6 +3200,7 @@
           <a:lstStyle xmlns:a="http://schemas.openxmlformats.org/drawingml/2006/main"/>
           <a:p xmlns:a="http://schemas.openxmlformats.org/drawingml/2006/main">
             <a:pPr algn="l">
+              <a:buNone/>
               <a:defRPr sz="1350" b="0">
                 <a:solidFill>
                   <a:srgbClr val="344054"/>
@@ -3259,6 +3285,7 @@
           <a:lstStyle xmlns:a="http://schemas.openxmlformats.org/drawingml/2006/main"/>
           <a:p xmlns:a="http://schemas.openxmlformats.org/drawingml/2006/main">
             <a:pPr algn="l">
+              <a:buNone/>
               <a:defRPr sz="1875" b="1">
                 <a:solidFill>
                   <a:srgbClr val="101828"/>
@@ -3311,6 +3338,7 @@
           <a:lstStyle xmlns:a="http://schemas.openxmlformats.org/drawingml/2006/main"/>
           <a:p xmlns:a="http://schemas.openxmlformats.org/drawingml/2006/main">
             <a:pPr algn="l">
+              <a:buNone/>
               <a:defRPr sz="1500" b="0">
                 <a:solidFill>
                   <a:srgbClr val="344054"/>
@@ -3333,6 +3361,7 @@
           </a:p>
           <a:p xmlns:a="http://schemas.openxmlformats.org/drawingml/2006/main">
             <a:pPr algn="l">
+              <a:buNone/>
               <a:defRPr sz="1500" b="0">
                 <a:solidFill>
                   <a:srgbClr val="344054"/>
@@ -3355,6 +3384,7 @@
           </a:p>
           <a:p xmlns:a="http://schemas.openxmlformats.org/drawingml/2006/main">
             <a:pPr algn="l">
+              <a:buNone/>
               <a:defRPr sz="1500" b="0">
                 <a:solidFill>
                   <a:srgbClr val="344054"/>
@@ -3377,6 +3407,7 @@
           </a:p>
           <a:p xmlns:a="http://schemas.openxmlformats.org/drawingml/2006/main">
             <a:pPr algn="l">
+              <a:buNone/>
               <a:defRPr sz="1500" b="0">
                 <a:solidFill>
                   <a:srgbClr val="344054"/>
@@ -3429,6 +3460,7 @@
           <a:lstStyle xmlns:a="http://schemas.openxmlformats.org/drawingml/2006/main"/>
           <a:p xmlns:a="http://schemas.openxmlformats.org/drawingml/2006/main">
             <a:pPr algn="l">
+              <a:buNone/>
               <a:defRPr sz="1275" b="1">
                 <a:solidFill>
                   <a:srgbClr val="6938EF"/>
@@ -3481,6 +3513,7 @@
           <a:lstStyle xmlns:a="http://schemas.openxmlformats.org/drawingml/2006/main"/>
           <a:p xmlns:a="http://schemas.openxmlformats.org/drawingml/2006/main">
             <a:pPr algn="l">
+              <a:buNone/>
               <a:defRPr sz="1425" b="1">
                 <a:solidFill>
                   <a:srgbClr val="101828"/>
@@ -3533,6 +3566,7 @@
           <a:lstStyle xmlns:a="http://schemas.openxmlformats.org/drawingml/2006/main"/>
           <a:p xmlns:a="http://schemas.openxmlformats.org/drawingml/2006/main">
             <a:pPr algn="l">
+              <a:buNone/>
               <a:defRPr sz="1800" b="1">
                 <a:solidFill>
                   <a:srgbClr val="2F80ED"/>
@@ -3646,6 +3680,7 @@
           <a:lstStyle xmlns:a="http://schemas.openxmlformats.org/drawingml/2006/main"/>
           <a:p xmlns:a="http://schemas.openxmlformats.org/drawingml/2006/main">
             <a:pPr algn="l">
+              <a:buNone/>
               <a:defRPr sz="975" b="1">
                 <a:solidFill>
                   <a:srgbClr val="2F80ED"/>
@@ -3698,6 +3733,7 @@
           <a:lstStyle xmlns:a="http://schemas.openxmlformats.org/drawingml/2006/main"/>
           <a:p xmlns:a="http://schemas.openxmlformats.org/drawingml/2006/main">
             <a:pPr algn="l">
+              <a:buNone/>
               <a:defRPr sz="2850" b="1">
                 <a:solidFill>
                   <a:srgbClr val="101828"/>
@@ -3750,6 +3786,7 @@
           <a:lstStyle xmlns:a="http://schemas.openxmlformats.org/drawingml/2006/main"/>
           <a:p xmlns:a="http://schemas.openxmlformats.org/drawingml/2006/main">
             <a:pPr algn="r">
+              <a:buNone/>
               <a:defRPr sz="975" b="1">
                 <a:solidFill>
                   <a:srgbClr val="98A2B3"/>
@@ -3802,6 +3839,7 @@
           <a:lstStyle xmlns:a="http://schemas.openxmlformats.org/drawingml/2006/main"/>
           <a:p xmlns:a="http://schemas.openxmlformats.org/drawingml/2006/main">
             <a:pPr algn="l">
+              <a:buNone/>
               <a:defRPr sz="1650" b="0">
                 <a:solidFill>
                   <a:srgbClr val="344054"/>
@@ -3889,6 +3927,7 @@
           <a:lstStyle xmlns:a="http://schemas.openxmlformats.org/drawingml/2006/main"/>
           <a:p xmlns:a="http://schemas.openxmlformats.org/drawingml/2006/main">
             <a:pPr algn="ctr">
+              <a:buNone/>
               <a:defRPr sz="1800" b="1">
                 <a:solidFill>
                   <a:srgbClr val="101828"/>
@@ -3941,6 +3980,7 @@
           <a:lstStyle xmlns:a="http://schemas.openxmlformats.org/drawingml/2006/main"/>
           <a:p xmlns:a="http://schemas.openxmlformats.org/drawingml/2006/main">
             <a:pPr algn="ctr">
+              <a:buNone/>
               <a:defRPr sz="1200" b="0">
                 <a:solidFill>
                   <a:srgbClr val="667085"/>
@@ -3993,6 +4033,7 @@
           <a:lstStyle xmlns:a="http://schemas.openxmlformats.org/drawingml/2006/main"/>
           <a:p xmlns:a="http://schemas.openxmlformats.org/drawingml/2006/main">
             <a:pPr algn="ctr">
+              <a:buNone/>
               <a:defRPr sz="2850" b="1">
                 <a:solidFill>
                   <a:srgbClr val="98A2B3"/>
@@ -4080,6 +4121,7 @@
           <a:lstStyle xmlns:a="http://schemas.openxmlformats.org/drawingml/2006/main"/>
           <a:p xmlns:a="http://schemas.openxmlformats.org/drawingml/2006/main">
             <a:pPr algn="ctr">
+              <a:buNone/>
               <a:defRPr sz="1800" b="1">
                 <a:solidFill>
                   <a:srgbClr val="D92D20"/>
@@ -4132,6 +4174,7 @@
           <a:lstStyle xmlns:a="http://schemas.openxmlformats.org/drawingml/2006/main"/>
           <a:p xmlns:a="http://schemas.openxmlformats.org/drawingml/2006/main">
             <a:pPr algn="ctr">
+              <a:buNone/>
               <a:defRPr sz="1200" b="0">
                 <a:solidFill>
                   <a:srgbClr val="D92D20"/>
@@ -4184,6 +4227,7 @@
           <a:lstStyle xmlns:a="http://schemas.openxmlformats.org/drawingml/2006/main"/>
           <a:p xmlns:a="http://schemas.openxmlformats.org/drawingml/2006/main">
             <a:pPr algn="ctr">
+              <a:buNone/>
               <a:defRPr sz="2850" b="1">
                 <a:solidFill>
                   <a:srgbClr val="98A2B3"/>
@@ -4271,6 +4315,7 @@
           <a:lstStyle xmlns:a="http://schemas.openxmlformats.org/drawingml/2006/main"/>
           <a:p xmlns:a="http://schemas.openxmlformats.org/drawingml/2006/main">
             <a:pPr algn="ctr">
+              <a:buNone/>
               <a:defRPr sz="1800" b="1">
                 <a:solidFill>
                   <a:srgbClr val="D92D20"/>
@@ -4323,6 +4368,7 @@
           <a:lstStyle xmlns:a="http://schemas.openxmlformats.org/drawingml/2006/main"/>
           <a:p xmlns:a="http://schemas.openxmlformats.org/drawingml/2006/main">
             <a:pPr algn="ctr">
+              <a:buNone/>
               <a:defRPr sz="1200" b="0">
                 <a:solidFill>
                   <a:srgbClr val="D92D20"/>
@@ -4407,6 +4453,7 @@
           <a:lstStyle xmlns:a="http://schemas.openxmlformats.org/drawingml/2006/main"/>
           <a:p xmlns:a="http://schemas.openxmlformats.org/drawingml/2006/main">
             <a:pPr algn="l">
+              <a:buNone/>
               <a:defRPr sz="1725" b="1">
                 <a:solidFill>
                   <a:srgbClr val="101828"/>
@@ -4459,6 +4506,7 @@
           <a:lstStyle xmlns:a="http://schemas.openxmlformats.org/drawingml/2006/main"/>
           <a:p xmlns:a="http://schemas.openxmlformats.org/drawingml/2006/main">
             <a:pPr algn="l">
+              <a:buNone/>
               <a:defRPr sz="1800" b="0">
                 <a:solidFill>
                   <a:srgbClr val="344054"/>
@@ -4511,6 +4559,7 @@
           <a:lstStyle xmlns:a="http://schemas.openxmlformats.org/drawingml/2006/main"/>
           <a:p xmlns:a="http://schemas.openxmlformats.org/drawingml/2006/main">
             <a:pPr algn="ctr">
+              <a:buNone/>
               <a:defRPr sz="1350" b="1">
                 <a:solidFill>
                   <a:srgbClr val="D92D20"/>
@@ -4563,6 +4612,7 @@
           <a:lstStyle xmlns:a="http://schemas.openxmlformats.org/drawingml/2006/main"/>
           <a:p xmlns:a="http://schemas.openxmlformats.org/drawingml/2006/main">
             <a:pPr algn="ctr">
+              <a:buNone/>
               <a:defRPr sz="2550" b="1">
                 <a:solidFill>
                   <a:srgbClr val="101828"/>
@@ -4676,6 +4726,7 @@
           <a:lstStyle xmlns:a="http://schemas.openxmlformats.org/drawingml/2006/main"/>
           <a:p xmlns:a="http://schemas.openxmlformats.org/drawingml/2006/main">
             <a:pPr algn="l">
+              <a:buNone/>
               <a:defRPr sz="975" b="1">
                 <a:solidFill>
                   <a:srgbClr val="2F80ED"/>
@@ -4728,6 +4779,7 @@
           <a:lstStyle xmlns:a="http://schemas.openxmlformats.org/drawingml/2006/main"/>
           <a:p xmlns:a="http://schemas.openxmlformats.org/drawingml/2006/main">
             <a:pPr algn="l">
+              <a:buNone/>
               <a:defRPr sz="2850" b="1">
                 <a:solidFill>
                   <a:srgbClr val="101828"/>
@@ -4780,6 +4832,7 @@
           <a:lstStyle xmlns:a="http://schemas.openxmlformats.org/drawingml/2006/main"/>
           <a:p xmlns:a="http://schemas.openxmlformats.org/drawingml/2006/main">
             <a:pPr algn="r">
+              <a:buNone/>
               <a:defRPr sz="975" b="1">
                 <a:solidFill>
                   <a:srgbClr val="98A2B3"/>
@@ -4896,6 +4949,7 @@
           <a:lstStyle xmlns:a="http://schemas.openxmlformats.org/drawingml/2006/main"/>
           <a:p xmlns:a="http://schemas.openxmlformats.org/drawingml/2006/main">
             <a:pPr algn="l">
+              <a:buNone/>
               <a:defRPr sz="1500" b="1">
                 <a:solidFill>
                   <a:srgbClr val="D92D20"/>
@@ -4948,6 +5002,7 @@
           <a:lstStyle xmlns:a="http://schemas.openxmlformats.org/drawingml/2006/main"/>
           <a:p xmlns:a="http://schemas.openxmlformats.org/drawingml/2006/main">
             <a:pPr algn="l">
+              <a:buNone/>
               <a:defRPr sz="2025" b="1">
                 <a:solidFill>
                   <a:srgbClr val="101828"/>
@@ -5000,6 +5055,7 @@
           <a:lstStyle xmlns:a="http://schemas.openxmlformats.org/drawingml/2006/main"/>
           <a:p xmlns:a="http://schemas.openxmlformats.org/drawingml/2006/main">
             <a:pPr algn="l">
+              <a:buNone/>
               <a:defRPr sz="1575" b="0">
                 <a:solidFill>
                   <a:srgbClr val="D92D20"/>
@@ -5052,6 +5108,7 @@
           <a:lstStyle xmlns:a="http://schemas.openxmlformats.org/drawingml/2006/main"/>
           <a:p xmlns:a="http://schemas.openxmlformats.org/drawingml/2006/main">
             <a:pPr algn="l">
+              <a:buNone/>
               <a:defRPr sz="1575" b="0">
                 <a:solidFill>
                   <a:srgbClr val="667085"/>
@@ -5104,6 +5161,7 @@
           <a:lstStyle xmlns:a="http://schemas.openxmlformats.org/drawingml/2006/main"/>
           <a:p xmlns:a="http://schemas.openxmlformats.org/drawingml/2006/main">
             <a:pPr algn="l">
+              <a:buNone/>
               <a:defRPr sz="1875" b="1">
                 <a:solidFill>
                   <a:srgbClr val="D92D20"/>
@@ -5156,6 +5214,7 @@
           <a:lstStyle xmlns:a="http://schemas.openxmlformats.org/drawingml/2006/main"/>
           <a:p xmlns:a="http://schemas.openxmlformats.org/drawingml/2006/main">
             <a:pPr algn="l">
+              <a:buNone/>
               <a:defRPr sz="1275" b="0">
                 <a:solidFill>
                   <a:srgbClr val="667085"/>
@@ -5208,6 +5267,7 @@
           <a:lstStyle xmlns:a="http://schemas.openxmlformats.org/drawingml/2006/main"/>
           <a:p xmlns:a="http://schemas.openxmlformats.org/drawingml/2006/main">
             <a:pPr algn="l">
+              <a:buNone/>
               <a:defRPr sz="1500" b="1">
                 <a:solidFill>
                   <a:srgbClr val="039855"/>
@@ -5260,6 +5320,7 @@
           <a:lstStyle xmlns:a="http://schemas.openxmlformats.org/drawingml/2006/main"/>
           <a:p xmlns:a="http://schemas.openxmlformats.org/drawingml/2006/main">
             <a:pPr algn="l">
+              <a:buNone/>
               <a:defRPr sz="2025" b="1">
                 <a:solidFill>
                   <a:srgbClr val="101828"/>
@@ -5312,6 +5373,7 @@
           <a:lstStyle xmlns:a="http://schemas.openxmlformats.org/drawingml/2006/main"/>
           <a:p xmlns:a="http://schemas.openxmlformats.org/drawingml/2006/main">
             <a:pPr algn="l">
+              <a:buNone/>
               <a:defRPr sz="1575" b="0">
                 <a:solidFill>
                   <a:srgbClr val="039855"/>
@@ -5364,6 +5426,7 @@
           <a:lstStyle xmlns:a="http://schemas.openxmlformats.org/drawingml/2006/main"/>
           <a:p xmlns:a="http://schemas.openxmlformats.org/drawingml/2006/main">
             <a:pPr algn="l">
+              <a:buNone/>
               <a:defRPr sz="1575" b="0">
                 <a:solidFill>
                   <a:srgbClr val="667085"/>
@@ -5416,6 +5479,7 @@
           <a:lstStyle xmlns:a="http://schemas.openxmlformats.org/drawingml/2006/main"/>
           <a:p xmlns:a="http://schemas.openxmlformats.org/drawingml/2006/main">
             <a:pPr algn="l">
+              <a:buNone/>
               <a:defRPr sz="1875" b="1">
                 <a:solidFill>
                   <a:srgbClr val="039855"/>
@@ -5468,6 +5532,7 @@
           <a:lstStyle xmlns:a="http://schemas.openxmlformats.org/drawingml/2006/main"/>
           <a:p xmlns:a="http://schemas.openxmlformats.org/drawingml/2006/main">
             <a:pPr algn="l">
+              <a:buNone/>
               <a:defRPr sz="1275" b="0">
                 <a:solidFill>
                   <a:srgbClr val="667085"/>
@@ -5581,6 +5646,7 @@
           <a:lstStyle xmlns:a="http://schemas.openxmlformats.org/drawingml/2006/main"/>
           <a:p xmlns:a="http://schemas.openxmlformats.org/drawingml/2006/main">
             <a:pPr algn="l">
+              <a:buNone/>
               <a:defRPr sz="975" b="1">
                 <a:solidFill>
                   <a:srgbClr val="2F80ED"/>
@@ -5633,6 +5699,7 @@
           <a:lstStyle xmlns:a="http://schemas.openxmlformats.org/drawingml/2006/main"/>
           <a:p xmlns:a="http://schemas.openxmlformats.org/drawingml/2006/main">
             <a:pPr algn="l">
+              <a:buNone/>
               <a:defRPr sz="2850" b="1">
                 <a:solidFill>
                   <a:srgbClr val="101828"/>
@@ -5685,6 +5752,7 @@
           <a:lstStyle xmlns:a="http://schemas.openxmlformats.org/drawingml/2006/main"/>
           <a:p xmlns:a="http://schemas.openxmlformats.org/drawingml/2006/main">
             <a:pPr algn="r">
+              <a:buNone/>
               <a:defRPr sz="975" b="1">
                 <a:solidFill>
                   <a:srgbClr val="98A2B3"/>
@@ -5737,6 +5805,7 @@
           <a:lstStyle xmlns:a="http://schemas.openxmlformats.org/drawingml/2006/main"/>
           <a:p xmlns:a="http://schemas.openxmlformats.org/drawingml/2006/main">
             <a:pPr algn="l">
+              <a:buNone/>
               <a:defRPr sz="1350" b="0">
                 <a:solidFill>
                   <a:srgbClr val="667085"/>
@@ -5756,17 +5825,17 @@
       </p:sp>
       <p:pic>
         <p:nvPicPr>
-          <p:cNvPr id="24" name=""/>
+          <p:cNvPr id="26" name=""/>
           <p:cNvPicPr>
             <a:picLocks xmlns:a="http://schemas.openxmlformats.org/drawingml/2006/main" noChangeAspect="1"/>
           </p:cNvPicPr>
           <p:nvPr/>
         </p:nvPicPr>
         <p:blipFill>
-          <a:blip xmlns:r="http://schemas.openxmlformats.org/officeDocument/2006/relationships" xmlns:a="http://schemas.openxmlformats.org/drawingml/2006/main" r:embed="Rafb95ac01b0547e7">
+          <a:blip xmlns:r="http://schemas.openxmlformats.org/officeDocument/2006/relationships" xmlns:a="http://schemas.openxmlformats.org/drawingml/2006/main" r:embed="R113268886aac412d">
             <a:extLst>
               <a:ext uri="{96DAC541-7B7A-43D3-8B79-37D633B846F1}">
-                <asvg:svgBlip xmlns:asvg="http://schemas.microsoft.com/office/drawing/2016/SVG/main" r:embed="Re40eae44de5044c8"/>
+                <asvg:svgBlip xmlns:asvg="http://schemas.microsoft.com/office/drawing/2016/SVG/main" r:embed="Rf323b014608a4364"/>
               </a:ext>
             </a:extLst>
           </a:blip>
@@ -5817,6 +5886,7 @@
           <a:lstStyle xmlns:a="http://schemas.openxmlformats.org/drawingml/2006/main"/>
           <a:p xmlns:a="http://schemas.openxmlformats.org/drawingml/2006/main">
             <a:pPr algn="l">
+              <a:buNone/>
               <a:defRPr sz="1350" b="1">
                 <a:solidFill>
                   <a:srgbClr val="2F80ED"/>
@@ -5869,6 +5939,7 @@
           <a:lstStyle xmlns:a="http://schemas.openxmlformats.org/drawingml/2006/main"/>
           <a:p xmlns:a="http://schemas.openxmlformats.org/drawingml/2006/main">
             <a:pPr algn="l">
+              <a:buNone/>
               <a:defRPr sz="1650" b="1">
                 <a:solidFill>
                   <a:srgbClr val="101828"/>
@@ -5921,6 +5992,7 @@
           <a:lstStyle xmlns:a="http://schemas.openxmlformats.org/drawingml/2006/main"/>
           <a:p xmlns:a="http://schemas.openxmlformats.org/drawingml/2006/main">
             <a:pPr algn="l">
+              <a:buNone/>
               <a:defRPr sz="1200" b="0">
                 <a:solidFill>
                   <a:srgbClr val="667085"/>
@@ -5973,6 +6045,7 @@
           <a:lstStyle xmlns:a="http://schemas.openxmlformats.org/drawingml/2006/main"/>
           <a:p xmlns:a="http://schemas.openxmlformats.org/drawingml/2006/main">
             <a:pPr algn="l">
+              <a:buNone/>
               <a:defRPr sz="1350" b="1">
                 <a:solidFill>
                   <a:srgbClr val="2F80ED"/>
@@ -6025,6 +6098,7 @@
           <a:lstStyle xmlns:a="http://schemas.openxmlformats.org/drawingml/2006/main"/>
           <a:p xmlns:a="http://schemas.openxmlformats.org/drawingml/2006/main">
             <a:pPr algn="l">
+              <a:buNone/>
               <a:defRPr sz="1650" b="1">
                 <a:solidFill>
                   <a:srgbClr val="101828"/>
@@ -6077,6 +6151,7 @@
           <a:lstStyle xmlns:a="http://schemas.openxmlformats.org/drawingml/2006/main"/>
           <a:p xmlns:a="http://schemas.openxmlformats.org/drawingml/2006/main">
             <a:pPr algn="l">
+              <a:buNone/>
               <a:defRPr sz="1200" b="0">
                 <a:solidFill>
                   <a:srgbClr val="667085"/>
@@ -6129,6 +6204,7 @@
           <a:lstStyle xmlns:a="http://schemas.openxmlformats.org/drawingml/2006/main"/>
           <a:p xmlns:a="http://schemas.openxmlformats.org/drawingml/2006/main">
             <a:pPr algn="l">
+              <a:buNone/>
               <a:defRPr sz="1350" b="1">
                 <a:solidFill>
                   <a:srgbClr val="2F80ED"/>
@@ -6181,6 +6257,7 @@
           <a:lstStyle xmlns:a="http://schemas.openxmlformats.org/drawingml/2006/main"/>
           <a:p xmlns:a="http://schemas.openxmlformats.org/drawingml/2006/main">
             <a:pPr algn="l">
+              <a:buNone/>
               <a:defRPr sz="1650" b="1">
                 <a:solidFill>
                   <a:srgbClr val="101828"/>
@@ -6233,6 +6310,7 @@
           <a:lstStyle xmlns:a="http://schemas.openxmlformats.org/drawingml/2006/main"/>
           <a:p xmlns:a="http://schemas.openxmlformats.org/drawingml/2006/main">
             <a:pPr algn="l">
+              <a:buNone/>
               <a:defRPr sz="1200" b="0">
                 <a:solidFill>
                   <a:srgbClr val="667085"/>
@@ -6285,6 +6363,7 @@
           <a:lstStyle xmlns:a="http://schemas.openxmlformats.org/drawingml/2006/main"/>
           <a:p xmlns:a="http://schemas.openxmlformats.org/drawingml/2006/main">
             <a:pPr algn="l">
+              <a:buNone/>
               <a:defRPr sz="1350" b="1">
                 <a:solidFill>
                   <a:srgbClr val="2F80ED"/>
@@ -6337,6 +6416,7 @@
           <a:lstStyle xmlns:a="http://schemas.openxmlformats.org/drawingml/2006/main"/>
           <a:p xmlns:a="http://schemas.openxmlformats.org/drawingml/2006/main">
             <a:pPr algn="l">
+              <a:buNone/>
               <a:defRPr sz="1650" b="1">
                 <a:solidFill>
                   <a:srgbClr val="101828"/>
@@ -6389,6 +6469,7 @@
           <a:lstStyle xmlns:a="http://schemas.openxmlformats.org/drawingml/2006/main"/>
           <a:p xmlns:a="http://schemas.openxmlformats.org/drawingml/2006/main">
             <a:pPr algn="l">
+              <a:buNone/>
               <a:defRPr sz="1200" b="0">
                 <a:solidFill>
                   <a:srgbClr val="667085"/>
@@ -6502,6 +6583,7 @@
           <a:lstStyle xmlns:a="http://schemas.openxmlformats.org/drawingml/2006/main"/>
           <a:p xmlns:a="http://schemas.openxmlformats.org/drawingml/2006/main">
             <a:pPr algn="l">
+              <a:buNone/>
               <a:defRPr sz="975" b="1">
                 <a:solidFill>
                   <a:srgbClr val="2F80ED"/>
@@ -6554,6 +6636,7 @@
           <a:lstStyle xmlns:a="http://schemas.openxmlformats.org/drawingml/2006/main"/>
           <a:p xmlns:a="http://schemas.openxmlformats.org/drawingml/2006/main">
             <a:pPr algn="l">
+              <a:buNone/>
               <a:defRPr sz="2850" b="1">
                 <a:solidFill>
                   <a:srgbClr val="101828"/>
@@ -6606,6 +6689,7 @@
           <a:lstStyle xmlns:a="http://schemas.openxmlformats.org/drawingml/2006/main"/>
           <a:p xmlns:a="http://schemas.openxmlformats.org/drawingml/2006/main">
             <a:pPr algn="r">
+              <a:buNone/>
               <a:defRPr sz="975" b="1">
                 <a:solidFill>
                   <a:srgbClr val="98A2B3"/>
@@ -6658,6 +6742,7 @@
           <a:lstStyle xmlns:a="http://schemas.openxmlformats.org/drawingml/2006/main"/>
           <a:p xmlns:a="http://schemas.openxmlformats.org/drawingml/2006/main">
             <a:pPr algn="l">
+              <a:buNone/>
               <a:defRPr sz="2850" b="1">
                 <a:solidFill>
                   <a:srgbClr val="2F80ED"/>
@@ -6710,6 +6795,7 @@
           <a:lstStyle xmlns:a="http://schemas.openxmlformats.org/drawingml/2006/main"/>
           <a:p xmlns:a="http://schemas.openxmlformats.org/drawingml/2006/main">
             <a:pPr algn="l">
+              <a:buNone/>
               <a:defRPr sz="1875" b="1">
                 <a:solidFill>
                   <a:srgbClr val="101828"/>
@@ -6762,6 +6848,7 @@
           <a:lstStyle xmlns:a="http://schemas.openxmlformats.org/drawingml/2006/main"/>
           <a:p xmlns:a="http://schemas.openxmlformats.org/drawingml/2006/main">
             <a:pPr algn="l">
+              <a:buNone/>
               <a:defRPr sz="1350" b="0">
                 <a:solidFill>
                   <a:srgbClr val="344054"/>
@@ -6779,6 +6866,7 @@
           </a:p>
           <a:p xmlns:a="http://schemas.openxmlformats.org/drawingml/2006/main">
             <a:pPr algn="l">
+              <a:buNone/>
               <a:defRPr sz="1350" b="0">
                 <a:solidFill>
                   <a:srgbClr val="344054"/>
@@ -6863,6 +6951,7 @@
           <a:lstStyle xmlns:a="http://schemas.openxmlformats.org/drawingml/2006/main"/>
           <a:p xmlns:a="http://schemas.openxmlformats.org/drawingml/2006/main">
             <a:pPr algn="l">
+              <a:buNone/>
               <a:defRPr sz="2850" b="1">
                 <a:solidFill>
                   <a:srgbClr val="6938EF"/>
@@ -6915,6 +7004,7 @@
           <a:lstStyle xmlns:a="http://schemas.openxmlformats.org/drawingml/2006/main"/>
           <a:p xmlns:a="http://schemas.openxmlformats.org/drawingml/2006/main">
             <a:pPr algn="l">
+              <a:buNone/>
               <a:defRPr sz="1875" b="1">
                 <a:solidFill>
                   <a:srgbClr val="101828"/>
@@ -6967,6 +7057,7 @@
           <a:lstStyle xmlns:a="http://schemas.openxmlformats.org/drawingml/2006/main"/>
           <a:p xmlns:a="http://schemas.openxmlformats.org/drawingml/2006/main">
             <a:pPr algn="ctr">
+              <a:buNone/>
               <a:defRPr sz="1650" b="1">
                 <a:solidFill>
                   <a:srgbClr val="2F80ED"/>
@@ -7019,6 +7110,7 @@
           <a:lstStyle xmlns:a="http://schemas.openxmlformats.org/drawingml/2006/main"/>
           <a:p xmlns:a="http://schemas.openxmlformats.org/drawingml/2006/main">
             <a:pPr algn="ctr">
+              <a:buNone/>
               <a:defRPr sz="1200" b="0">
                 <a:solidFill>
                   <a:srgbClr val="667085"/>
@@ -7071,6 +7163,7 @@
           <a:lstStyle xmlns:a="http://schemas.openxmlformats.org/drawingml/2006/main"/>
           <a:p xmlns:a="http://schemas.openxmlformats.org/drawingml/2006/main">
             <a:pPr algn="ctr">
+              <a:buNone/>
               <a:defRPr sz="1650" b="1">
                 <a:solidFill>
                   <a:srgbClr val="6938EF"/>
@@ -7123,6 +7216,7 @@
           <a:lstStyle xmlns:a="http://schemas.openxmlformats.org/drawingml/2006/main"/>
           <a:p xmlns:a="http://schemas.openxmlformats.org/drawingml/2006/main">
             <a:pPr algn="ctr">
+              <a:buNone/>
               <a:defRPr sz="1200" b="0">
                 <a:solidFill>
                   <a:srgbClr val="667085"/>
@@ -7175,6 +7269,7 @@
           <a:lstStyle xmlns:a="http://schemas.openxmlformats.org/drawingml/2006/main"/>
           <a:p xmlns:a="http://schemas.openxmlformats.org/drawingml/2006/main">
             <a:pPr algn="ctr">
+              <a:buNone/>
               <a:defRPr sz="1650" b="1">
                 <a:solidFill>
                   <a:srgbClr val="DC6803"/>
@@ -7227,6 +7322,7 @@
           <a:lstStyle xmlns:a="http://schemas.openxmlformats.org/drawingml/2006/main"/>
           <a:p xmlns:a="http://schemas.openxmlformats.org/drawingml/2006/main">
             <a:pPr algn="ctr">
+              <a:buNone/>
               <a:defRPr sz="1200" b="0">
                 <a:solidFill>
                   <a:srgbClr val="667085"/>
@@ -7311,6 +7407,7 @@
           <a:lstStyle xmlns:a="http://schemas.openxmlformats.org/drawingml/2006/main"/>
           <a:p xmlns:a="http://schemas.openxmlformats.org/drawingml/2006/main">
             <a:pPr algn="l">
+              <a:buNone/>
               <a:defRPr sz="2850" b="1">
                 <a:solidFill>
                   <a:srgbClr val="039855"/>
@@ -7363,6 +7460,7 @@
           <a:lstStyle xmlns:a="http://schemas.openxmlformats.org/drawingml/2006/main"/>
           <a:p xmlns:a="http://schemas.openxmlformats.org/drawingml/2006/main">
             <a:pPr algn="l">
+              <a:buNone/>
               <a:defRPr sz="1875" b="1">
                 <a:solidFill>
                   <a:srgbClr val="101828"/>
@@ -7415,6 +7513,7 @@
           <a:lstStyle xmlns:a="http://schemas.openxmlformats.org/drawingml/2006/main"/>
           <a:p xmlns:a="http://schemas.openxmlformats.org/drawingml/2006/main">
             <a:pPr algn="l">
+              <a:buNone/>
               <a:defRPr sz="1350" b="0">
                 <a:solidFill>
                   <a:srgbClr val="344054"/>
@@ -7467,6 +7566,7 @@
           <a:lstStyle xmlns:a="http://schemas.openxmlformats.org/drawingml/2006/main"/>
           <a:p xmlns:a="http://schemas.openxmlformats.org/drawingml/2006/main">
             <a:pPr algn="ctr">
+              <a:buNone/>
               <a:defRPr sz="1200" b="1">
                 <a:solidFill>
                   <a:srgbClr val="667085"/>
@@ -7519,6 +7619,7 @@
           <a:lstStyle xmlns:a="http://schemas.openxmlformats.org/drawingml/2006/main"/>
           <a:p xmlns:a="http://schemas.openxmlformats.org/drawingml/2006/main">
             <a:pPr algn="ctr">
+              <a:buNone/>
               <a:defRPr sz="1650" b="1">
                 <a:solidFill>
                   <a:srgbClr val="101828"/>
@@ -7571,6 +7672,7 @@
           <a:lstStyle xmlns:a="http://schemas.openxmlformats.org/drawingml/2006/main"/>
           <a:p xmlns:a="http://schemas.openxmlformats.org/drawingml/2006/main">
             <a:pPr algn="ctr">
+              <a:buNone/>
               <a:defRPr sz="1200" b="0">
                 <a:solidFill>
                   <a:srgbClr val="039855"/>
@@ -7684,6 +7786,7 @@
           <a:lstStyle xmlns:a="http://schemas.openxmlformats.org/drawingml/2006/main"/>
           <a:p xmlns:a="http://schemas.openxmlformats.org/drawingml/2006/main">
             <a:pPr algn="l">
+              <a:buNone/>
               <a:defRPr sz="975" b="1">
                 <a:solidFill>
                   <a:srgbClr val="2F80ED"/>
@@ -7736,6 +7839,7 @@
           <a:lstStyle xmlns:a="http://schemas.openxmlformats.org/drawingml/2006/main"/>
           <a:p xmlns:a="http://schemas.openxmlformats.org/drawingml/2006/main">
             <a:pPr algn="l">
+              <a:buNone/>
               <a:defRPr sz="2850" b="1">
                 <a:solidFill>
                   <a:srgbClr val="101828"/>
@@ -7788,6 +7892,7 @@
           <a:lstStyle xmlns:a="http://schemas.openxmlformats.org/drawingml/2006/main"/>
           <a:p xmlns:a="http://schemas.openxmlformats.org/drawingml/2006/main">
             <a:pPr algn="r">
+              <a:buNone/>
               <a:defRPr sz="975" b="1">
                 <a:solidFill>
                   <a:srgbClr val="98A2B3"/>
@@ -7840,6 +7945,7 @@
           <a:lstStyle xmlns:a="http://schemas.openxmlformats.org/drawingml/2006/main"/>
           <a:p xmlns:a="http://schemas.openxmlformats.org/drawingml/2006/main">
             <a:pPr algn="l">
+              <a:buNone/>
               <a:defRPr sz="4200" b="1">
                 <a:solidFill>
                   <a:srgbClr val="101828"/>
@@ -7892,6 +7998,7 @@
           <a:lstStyle xmlns:a="http://schemas.openxmlformats.org/drawingml/2006/main"/>
           <a:p xmlns:a="http://schemas.openxmlformats.org/drawingml/2006/main">
             <a:pPr algn="l">
+              <a:buNone/>
               <a:defRPr sz="1650" b="0">
                 <a:solidFill>
                   <a:srgbClr val="344054"/>
@@ -7944,6 +8051,7 @@
           <a:lstStyle xmlns:a="http://schemas.openxmlformats.org/drawingml/2006/main"/>
           <a:p xmlns:a="http://schemas.openxmlformats.org/drawingml/2006/main">
             <a:pPr algn="l">
+              <a:buNone/>
               <a:defRPr sz="1275" b="1">
                 <a:solidFill>
                   <a:srgbClr val="6938EF"/>
@@ -7996,6 +8104,7 @@
           <a:lstStyle xmlns:a="http://schemas.openxmlformats.org/drawingml/2006/main"/>
           <a:p xmlns:a="http://schemas.openxmlformats.org/drawingml/2006/main">
             <a:pPr algn="l">
+              <a:buNone/>
               <a:defRPr sz="1275" b="1">
                 <a:solidFill>
                   <a:srgbClr val="6938EF"/>
@@ -8048,6 +8157,7 @@
           <a:lstStyle xmlns:a="http://schemas.openxmlformats.org/drawingml/2006/main"/>
           <a:p xmlns:a="http://schemas.openxmlformats.org/drawingml/2006/main">
             <a:pPr algn="l">
+              <a:buNone/>
               <a:defRPr sz="1275" b="1">
                 <a:solidFill>
                   <a:srgbClr val="6938EF"/>
@@ -8100,6 +8210,7 @@
           <a:lstStyle xmlns:a="http://schemas.openxmlformats.org/drawingml/2006/main"/>
           <a:p xmlns:a="http://schemas.openxmlformats.org/drawingml/2006/main">
             <a:pPr algn="l">
+              <a:buNone/>
               <a:defRPr sz="1650" b="1">
                 <a:solidFill>
                   <a:srgbClr val="DC6803"/>
@@ -8187,6 +8298,7 @@
           <a:lstStyle xmlns:a="http://schemas.openxmlformats.org/drawingml/2006/main"/>
           <a:p xmlns:a="http://schemas.openxmlformats.org/drawingml/2006/main">
             <a:pPr algn="ctr">
+              <a:buNone/>
               <a:defRPr sz="1575" b="1">
                 <a:solidFill>
                   <a:srgbClr val="101828"/>
@@ -8239,6 +8351,7 @@
           <a:lstStyle xmlns:a="http://schemas.openxmlformats.org/drawingml/2006/main"/>
           <a:p xmlns:a="http://schemas.openxmlformats.org/drawingml/2006/main">
             <a:pPr algn="ctr">
+              <a:buNone/>
               <a:defRPr sz="1800" b="1">
                 <a:solidFill>
                   <a:srgbClr val="98A2B3"/>
@@ -8326,6 +8439,7 @@
           <a:lstStyle xmlns:a="http://schemas.openxmlformats.org/drawingml/2006/main"/>
           <a:p xmlns:a="http://schemas.openxmlformats.org/drawingml/2006/main">
             <a:pPr algn="ctr">
+              <a:buNone/>
               <a:defRPr sz="1575" b="1">
                 <a:solidFill>
                   <a:srgbClr val="DC6803"/>
@@ -8378,6 +8492,7 @@
           <a:lstStyle xmlns:a="http://schemas.openxmlformats.org/drawingml/2006/main"/>
           <a:p xmlns:a="http://schemas.openxmlformats.org/drawingml/2006/main">
             <a:pPr algn="ctr">
+              <a:buNone/>
               <a:defRPr sz="1800" b="1">
                 <a:solidFill>
                   <a:srgbClr val="98A2B3"/>
@@ -8465,6 +8580,7 @@
           <a:lstStyle xmlns:a="http://schemas.openxmlformats.org/drawingml/2006/main"/>
           <a:p xmlns:a="http://schemas.openxmlformats.org/drawingml/2006/main">
             <a:pPr algn="ctr">
+              <a:buNone/>
               <a:defRPr sz="1575" b="1">
                 <a:solidFill>
                   <a:srgbClr val="101828"/>
@@ -8517,6 +8633,7 @@
           <a:lstStyle xmlns:a="http://schemas.openxmlformats.org/drawingml/2006/main"/>
           <a:p xmlns:a="http://schemas.openxmlformats.org/drawingml/2006/main">
             <a:pPr algn="ctr">
+              <a:buNone/>
               <a:defRPr sz="1800" b="1">
                 <a:solidFill>
                   <a:srgbClr val="98A2B3"/>
@@ -8604,6 +8721,7 @@
           <a:lstStyle xmlns:a="http://schemas.openxmlformats.org/drawingml/2006/main"/>
           <a:p xmlns:a="http://schemas.openxmlformats.org/drawingml/2006/main">
             <a:pPr algn="ctr">
+              <a:buNone/>
               <a:defRPr sz="1575" b="1">
                 <a:solidFill>
                   <a:srgbClr val="101828"/>
@@ -8656,6 +8774,7 @@
           <a:lstStyle xmlns:a="http://schemas.openxmlformats.org/drawingml/2006/main"/>
           <a:p xmlns:a="http://schemas.openxmlformats.org/drawingml/2006/main">
             <a:pPr algn="ctr">
+              <a:buNone/>
               <a:defRPr sz="1800" b="1">
                 <a:solidFill>
                   <a:srgbClr val="98A2B3"/>
@@ -8743,6 +8862,7 @@
           <a:lstStyle xmlns:a="http://schemas.openxmlformats.org/drawingml/2006/main"/>
           <a:p xmlns:a="http://schemas.openxmlformats.org/drawingml/2006/main">
             <a:pPr algn="ctr">
+              <a:buNone/>
               <a:defRPr sz="1575" b="1">
                 <a:solidFill>
                   <a:srgbClr val="101828"/>
@@ -8856,6 +8976,7 @@
           <a:lstStyle xmlns:a="http://schemas.openxmlformats.org/drawingml/2006/main"/>
           <a:p xmlns:a="http://schemas.openxmlformats.org/drawingml/2006/main">
             <a:pPr algn="l">
+              <a:buNone/>
               <a:defRPr sz="975" b="1">
                 <a:solidFill>
                   <a:srgbClr val="2F80ED"/>
@@ -8908,6 +9029,7 @@
           <a:lstStyle xmlns:a="http://schemas.openxmlformats.org/drawingml/2006/main"/>
           <a:p xmlns:a="http://schemas.openxmlformats.org/drawingml/2006/main">
             <a:pPr algn="l">
+              <a:buNone/>
               <a:defRPr sz="2850" b="1">
                 <a:solidFill>
                   <a:srgbClr val="101828"/>
@@ -8960,6 +9082,7 @@
           <a:lstStyle xmlns:a="http://schemas.openxmlformats.org/drawingml/2006/main"/>
           <a:p xmlns:a="http://schemas.openxmlformats.org/drawingml/2006/main">
             <a:pPr algn="r">
+              <a:buNone/>
               <a:defRPr sz="975" b="1">
                 <a:solidFill>
                   <a:srgbClr val="98A2B3"/>
@@ -9012,6 +9135,7 @@
           <a:lstStyle xmlns:a="http://schemas.openxmlformats.org/drawingml/2006/main"/>
           <a:p xmlns:a="http://schemas.openxmlformats.org/drawingml/2006/main">
             <a:pPr algn="ctr">
+              <a:buNone/>
               <a:defRPr sz="2250" b="1">
                 <a:solidFill>
                   <a:srgbClr val="101828"/>
@@ -9064,6 +9188,7 @@
           <a:lstStyle xmlns:a="http://schemas.openxmlformats.org/drawingml/2006/main"/>
           <a:p xmlns:a="http://schemas.openxmlformats.org/drawingml/2006/main">
             <a:pPr algn="ctr">
+              <a:buNone/>
               <a:defRPr sz="2850" b="1">
                 <a:solidFill>
                   <a:srgbClr val="98A2B3"/>
@@ -9116,6 +9241,7 @@
           <a:lstStyle xmlns:a="http://schemas.openxmlformats.org/drawingml/2006/main"/>
           <a:p xmlns:a="http://schemas.openxmlformats.org/drawingml/2006/main">
             <a:pPr algn="ctr">
+              <a:buNone/>
               <a:defRPr sz="2850" b="1">
                 <a:solidFill>
                   <a:srgbClr val="98A2B3"/>
@@ -9203,6 +9329,7 @@
           <a:lstStyle xmlns:a="http://schemas.openxmlformats.org/drawingml/2006/main"/>
           <a:p xmlns:a="http://schemas.openxmlformats.org/drawingml/2006/main">
             <a:pPr algn="l">
+              <a:buNone/>
               <a:defRPr sz="1425" b="1">
                 <a:solidFill>
                   <a:srgbClr val="D92D20"/>
@@ -9255,6 +9382,7 @@
           <a:lstStyle xmlns:a="http://schemas.openxmlformats.org/drawingml/2006/main"/>
           <a:p xmlns:a="http://schemas.openxmlformats.org/drawingml/2006/main">
             <a:pPr algn="l">
+              <a:buNone/>
               <a:defRPr sz="2175" b="1">
                 <a:solidFill>
                   <a:srgbClr val="101828"/>
@@ -9307,6 +9435,7 @@
           <a:lstStyle xmlns:a="http://schemas.openxmlformats.org/drawingml/2006/main"/>
           <a:p xmlns:a="http://schemas.openxmlformats.org/drawingml/2006/main">
             <a:pPr algn="l">
+              <a:buNone/>
               <a:defRPr sz="1425" b="0">
                 <a:solidFill>
                   <a:srgbClr val="344054"/>
@@ -9324,6 +9453,7 @@
           </a:p>
           <a:p xmlns:a="http://schemas.openxmlformats.org/drawingml/2006/main">
             <a:pPr algn="l">
+              <a:buNone/>
               <a:defRPr sz="1425" b="0">
                 <a:solidFill>
                   <a:srgbClr val="344054"/>
@@ -9341,6 +9471,7 @@
           </a:p>
           <a:p xmlns:a="http://schemas.openxmlformats.org/drawingml/2006/main">
             <a:pPr algn="l">
+              <a:buNone/>
               <a:defRPr sz="1425" b="0">
                 <a:solidFill>
                   <a:srgbClr val="344054"/>
@@ -9428,6 +9559,7 @@
           <a:lstStyle xmlns:a="http://schemas.openxmlformats.org/drawingml/2006/main"/>
           <a:p xmlns:a="http://schemas.openxmlformats.org/drawingml/2006/main">
             <a:pPr algn="l">
+              <a:buNone/>
               <a:defRPr sz="1425" b="1">
                 <a:solidFill>
                   <a:srgbClr val="039855"/>
@@ -9480,6 +9612,7 @@
           <a:lstStyle xmlns:a="http://schemas.openxmlformats.org/drawingml/2006/main"/>
           <a:p xmlns:a="http://schemas.openxmlformats.org/drawingml/2006/main">
             <a:pPr algn="l">
+              <a:buNone/>
               <a:defRPr sz="2025" b="1">
                 <a:solidFill>
                   <a:srgbClr val="101828"/>
@@ -9532,6 +9665,7 @@
           <a:lstStyle xmlns:a="http://schemas.openxmlformats.org/drawingml/2006/main"/>
           <a:p xmlns:a="http://schemas.openxmlformats.org/drawingml/2006/main">
             <a:pPr algn="l">
+              <a:buNone/>
               <a:defRPr sz="1425" b="0">
                 <a:solidFill>
                   <a:srgbClr val="344054"/>
@@ -9549,6 +9683,7 @@
           </a:p>
           <a:p xmlns:a="http://schemas.openxmlformats.org/drawingml/2006/main">
             <a:pPr algn="l">
+              <a:buNone/>
               <a:defRPr sz="1425" b="0">
                 <a:solidFill>
                   <a:srgbClr val="344054"/>
@@ -9566,6 +9701,7 @@
           </a:p>
           <a:p xmlns:a="http://schemas.openxmlformats.org/drawingml/2006/main">
             <a:pPr algn="l">
+              <a:buNone/>
               <a:defRPr sz="1425" b="0">
                 <a:solidFill>
                   <a:srgbClr val="344054"/>
@@ -9618,6 +9754,7 @@
           <a:lstStyle xmlns:a="http://schemas.openxmlformats.org/drawingml/2006/main"/>
           <a:p xmlns:a="http://schemas.openxmlformats.org/drawingml/2006/main">
             <a:pPr algn="ctr">
+              <a:buNone/>
               <a:defRPr sz="1350" b="1">
                 <a:solidFill>
                   <a:srgbClr val="DC6803"/>
@@ -9731,6 +9868,7 @@
           <a:lstStyle xmlns:a="http://schemas.openxmlformats.org/drawingml/2006/main"/>
           <a:p xmlns:a="http://schemas.openxmlformats.org/drawingml/2006/main">
             <a:pPr algn="l">
+              <a:buNone/>
               <a:defRPr sz="975" b="1">
                 <a:solidFill>
                   <a:srgbClr val="2F80ED"/>
@@ -9783,6 +9921,7 @@
           <a:lstStyle xmlns:a="http://schemas.openxmlformats.org/drawingml/2006/main"/>
           <a:p xmlns:a="http://schemas.openxmlformats.org/drawingml/2006/main">
             <a:pPr algn="l">
+              <a:buNone/>
               <a:defRPr sz="2850" b="1">
                 <a:solidFill>
                   <a:srgbClr val="101828"/>
@@ -9795,7 +9934,7 @@
                   <a:srgbClr val="101828"/>
                 </a:solidFill>
               </a:rPr>
-              <a:t>Desktop demo: один інтерфейс для проєкту, чатів і джерел</a:t>
+              <a:t>Desktop demo: сфокусований чат без зайвих панелей</a:t>
             </a:r>
           </a:p>
         </p:txBody>
@@ -9835,6 +9974,7 @@
           <a:lstStyle xmlns:a="http://schemas.openxmlformats.org/drawingml/2006/main"/>
           <a:p xmlns:a="http://schemas.openxmlformats.org/drawingml/2006/main">
             <a:pPr algn="r">
+              <a:buNone/>
               <a:defRPr sz="975" b="1">
                 <a:solidFill>
                   <a:srgbClr val="98A2B3"/>
@@ -9854,15 +9994,18 @@
       </p:sp>
       <p:pic>
         <p:nvPicPr>
-          <p:cNvPr id="21" name=""/>
+          <p:cNvPr id="23" name=""/>
           <p:cNvPicPr>
             <a:picLocks xmlns:a="http://schemas.openxmlformats.org/drawingml/2006/main" noChangeAspect="1"/>
           </p:cNvPicPr>
           <p:nvPr/>
         </p:nvPicPr>
         <p:blipFill>
-          <a:blip xmlns:r="http://schemas.openxmlformats.org/officeDocument/2006/relationships" xmlns:a="http://schemas.openxmlformats.org/drawingml/2006/main" r:embed="R3e2821c63b27439a"/>
-          <a:stretch xmlns:a="http://schemas.openxmlformats.org/drawingml/2006/main"/>
+          <a:blip xmlns:r="http://schemas.openxmlformats.org/officeDocument/2006/relationships" xmlns:a="http://schemas.openxmlformats.org/drawingml/2006/main" r:embed="R7ee30a642d1c48a3"/>
+          <a:srcRect xmlns:a="http://schemas.openxmlformats.org/drawingml/2006/main" l="0" t="0" r="0" b="0"/>
+          <a:stretch xmlns:a="http://schemas.openxmlformats.org/drawingml/2006/main">
+            <a:fillRect l="0" t="0" r="0" b="0"/>
+          </a:stretch>
         </p:blipFill>
         <p:spPr>
           <a:xfrm xmlns:a="http://schemas.openxmlformats.org/drawingml/2006/main">
@@ -9911,6 +10054,7 @@
           <a:lstStyle xmlns:a="http://schemas.openxmlformats.org/drawingml/2006/main"/>
           <a:p xmlns:a="http://schemas.openxmlformats.org/drawingml/2006/main">
             <a:pPr algn="l">
+              <a:buNone/>
               <a:defRPr sz="1350" b="1">
                 <a:solidFill>
                   <a:srgbClr val="2F80ED"/>
@@ -9963,6 +10107,7 @@
           <a:lstStyle xmlns:a="http://schemas.openxmlformats.org/drawingml/2006/main"/>
           <a:p xmlns:a="http://schemas.openxmlformats.org/drawingml/2006/main">
             <a:pPr algn="l">
+              <a:buNone/>
               <a:defRPr sz="1350" b="1">
                 <a:solidFill>
                   <a:srgbClr val="101828"/>
@@ -9980,6 +10125,7 @@
           </a:p>
           <a:p xmlns:a="http://schemas.openxmlformats.org/drawingml/2006/main">
             <a:pPr algn="l">
+              <a:buNone/>
               <a:defRPr sz="1350" b="1">
                 <a:solidFill>
                   <a:srgbClr val="101828"/>
@@ -10064,6 +10210,7 @@
           <a:lstStyle xmlns:a="http://schemas.openxmlformats.org/drawingml/2006/main"/>
           <a:p xmlns:a="http://schemas.openxmlformats.org/drawingml/2006/main">
             <a:pPr algn="l">
+              <a:buNone/>
               <a:defRPr sz="1350" b="1">
                 <a:solidFill>
                   <a:srgbClr val="2F80ED"/>
@@ -10116,6 +10263,7 @@
           <a:lstStyle xmlns:a="http://schemas.openxmlformats.org/drawingml/2006/main"/>
           <a:p xmlns:a="http://schemas.openxmlformats.org/drawingml/2006/main">
             <a:pPr algn="l">
+              <a:buNone/>
               <a:defRPr sz="1350" b="1">
                 <a:solidFill>
                   <a:srgbClr val="101828"/>
@@ -10128,11 +10276,12 @@
                   <a:srgbClr val="101828"/>
                 </a:solidFill>
               </a:rPr>
-              <a:t>Corpus tree</a:t>
+              <a:t>Швидке перемикання</a:t>
             </a:r>
           </a:p>
           <a:p xmlns:a="http://schemas.openxmlformats.org/drawingml/2006/main">
             <a:pPr algn="l">
+              <a:buNone/>
               <a:defRPr sz="1350" b="1">
                 <a:solidFill>
                   <a:srgbClr val="101828"/>
@@ -10145,7 +10294,7 @@
                   <a:srgbClr val="101828"/>
                 </a:solidFill>
               </a:rPr>
-              <a:t>і file preview</a:t>
+              <a:t>між чатами</a:t>
             </a:r>
           </a:p>
         </p:txBody>
@@ -10217,6 +10366,7 @@
           <a:lstStyle xmlns:a="http://schemas.openxmlformats.org/drawingml/2006/main"/>
           <a:p xmlns:a="http://schemas.openxmlformats.org/drawingml/2006/main">
             <a:pPr algn="l">
+              <a:buNone/>
               <a:defRPr sz="1350" b="1">
                 <a:solidFill>
                   <a:srgbClr val="2F80ED"/>
@@ -10269,6 +10419,7 @@
           <a:lstStyle xmlns:a="http://schemas.openxmlformats.org/drawingml/2006/main"/>
           <a:p xmlns:a="http://schemas.openxmlformats.org/drawingml/2006/main">
             <a:pPr algn="l">
+              <a:buNone/>
               <a:defRPr sz="1350" b="1">
                 <a:solidFill>
                   <a:srgbClr val="101828"/>
@@ -10281,11 +10432,12 @@
                   <a:srgbClr val="101828"/>
                 </a:solidFill>
               </a:rPr>
-              <a:t>Dependency graph</a:t>
+              <a:t>Corpus selector</a:t>
             </a:r>
           </a:p>
           <a:p xmlns:a="http://schemas.openxmlformats.org/drawingml/2006/main">
             <a:pPr algn="l">
+              <a:buNone/>
               <a:defRPr sz="1350" b="1">
                 <a:solidFill>
                   <a:srgbClr val="101828"/>
@@ -10298,7 +10450,7 @@
                   <a:srgbClr val="101828"/>
                 </a:solidFill>
               </a:rPr>
-              <a:t>та citations</a:t>
+              <a:t>і точні citations</a:t>
             </a:r>
           </a:p>
         </p:txBody>
@@ -10370,6 +10522,7 @@
           <a:lstStyle xmlns:a="http://schemas.openxmlformats.org/drawingml/2006/main"/>
           <a:p xmlns:a="http://schemas.openxmlformats.org/drawingml/2006/main">
             <a:pPr algn="l">
+              <a:buNone/>
               <a:defRPr sz="1725" b="1">
                 <a:solidFill>
                   <a:srgbClr val="039855"/>
@@ -10422,6 +10575,7 @@
           <a:lstStyle xmlns:a="http://schemas.openxmlformats.org/drawingml/2006/main"/>
           <a:p xmlns:a="http://schemas.openxmlformats.org/drawingml/2006/main">
             <a:pPr algn="l">
+              <a:buNone/>
               <a:defRPr sz="1350" b="1">
                 <a:solidFill>
                   <a:srgbClr val="101828"/>
@@ -10439,6 +10593,7 @@
           </a:p>
           <a:p xmlns:a="http://schemas.openxmlformats.org/drawingml/2006/main">
             <a:pPr algn="l">
+              <a:buNone/>
               <a:defRPr sz="1350" b="1">
                 <a:solidFill>
                   <a:srgbClr val="101828"/>
@@ -10552,6 +10707,7 @@
           <a:lstStyle xmlns:a="http://schemas.openxmlformats.org/drawingml/2006/main"/>
           <a:p xmlns:a="http://schemas.openxmlformats.org/drawingml/2006/main">
             <a:pPr algn="l">
+              <a:buNone/>
               <a:defRPr sz="975" b="1">
                 <a:solidFill>
                   <a:srgbClr val="2F80ED"/>
@@ -10604,6 +10760,7 @@
           <a:lstStyle xmlns:a="http://schemas.openxmlformats.org/drawingml/2006/main"/>
           <a:p xmlns:a="http://schemas.openxmlformats.org/drawingml/2006/main">
             <a:pPr algn="l">
+              <a:buNone/>
               <a:defRPr sz="2850" b="1">
                 <a:solidFill>
                   <a:srgbClr val="101828"/>
@@ -10656,6 +10813,7 @@
           <a:lstStyle xmlns:a="http://schemas.openxmlformats.org/drawingml/2006/main"/>
           <a:p xmlns:a="http://schemas.openxmlformats.org/drawingml/2006/main">
             <a:pPr algn="r">
+              <a:buNone/>
               <a:defRPr sz="975" b="1">
                 <a:solidFill>
                   <a:srgbClr val="98A2B3"/>
@@ -10708,6 +10866,7 @@
           <a:lstStyle xmlns:a="http://schemas.openxmlformats.org/drawingml/2006/main"/>
           <a:p xmlns:a="http://schemas.openxmlformats.org/drawingml/2006/main">
             <a:pPr algn="ctr">
+              <a:buNone/>
               <a:defRPr sz="5100" b="1">
                 <a:solidFill>
                   <a:srgbClr val="2F80ED"/>
@@ -10720,7 +10879,7 @@
                   <a:srgbClr val="2F80ED"/>
                 </a:solidFill>
               </a:rPr>
-              <a:t>41</a:t>
+              <a:t>44</a:t>
             </a:r>
           </a:p>
         </p:txBody>
@@ -10760,6 +10919,7 @@
           <a:lstStyle xmlns:a="http://schemas.openxmlformats.org/drawingml/2006/main"/>
           <a:p xmlns:a="http://schemas.openxmlformats.org/drawingml/2006/main">
             <a:pPr algn="ctr">
+              <a:buNone/>
               <a:defRPr sz="1650" b="1">
                 <a:solidFill>
                   <a:srgbClr val="101828"/>
@@ -10812,6 +10972,7 @@
           <a:lstStyle xmlns:a="http://schemas.openxmlformats.org/drawingml/2006/main"/>
           <a:p xmlns:a="http://schemas.openxmlformats.org/drawingml/2006/main">
             <a:pPr algn="ctr">
+              <a:buNone/>
               <a:defRPr sz="5100" b="1">
                 <a:solidFill>
                   <a:srgbClr val="039855"/>
@@ -10864,6 +11025,7 @@
           <a:lstStyle xmlns:a="http://schemas.openxmlformats.org/drawingml/2006/main"/>
           <a:p xmlns:a="http://schemas.openxmlformats.org/drawingml/2006/main">
             <a:pPr algn="ctr">
+              <a:buNone/>
               <a:defRPr sz="1650" b="1">
                 <a:solidFill>
                   <a:srgbClr val="101828"/>
@@ -10916,6 +11078,7 @@
           <a:lstStyle xmlns:a="http://schemas.openxmlformats.org/drawingml/2006/main"/>
           <a:p xmlns:a="http://schemas.openxmlformats.org/drawingml/2006/main">
             <a:pPr algn="ctr">
+              <a:buNone/>
               <a:defRPr sz="5100" b="1">
                 <a:solidFill>
                   <a:srgbClr val="6938EF"/>
@@ -10968,6 +11131,7 @@
           <a:lstStyle xmlns:a="http://schemas.openxmlformats.org/drawingml/2006/main"/>
           <a:p xmlns:a="http://schemas.openxmlformats.org/drawingml/2006/main">
             <a:pPr algn="ctr">
+              <a:buNone/>
               <a:defRPr sz="1650" b="1">
                 <a:solidFill>
                   <a:srgbClr val="101828"/>
@@ -11052,6 +11216,7 @@
           <a:lstStyle xmlns:a="http://schemas.openxmlformats.org/drawingml/2006/main"/>
           <a:p xmlns:a="http://schemas.openxmlformats.org/drawingml/2006/main">
             <a:pPr algn="l">
+              <a:buNone/>
               <a:defRPr sz="2250" b="1">
                 <a:solidFill>
                   <a:srgbClr val="101828"/>
@@ -11104,6 +11269,7 @@
           <a:lstStyle xmlns:a="http://schemas.openxmlformats.org/drawingml/2006/main"/>
           <a:p xmlns:a="http://schemas.openxmlformats.org/drawingml/2006/main">
             <a:pPr algn="l">
+              <a:buNone/>
               <a:defRPr sz="1425" b="0">
                 <a:solidFill>
                   <a:srgbClr val="344054"/>
@@ -11156,6 +11322,7 @@
           <a:lstStyle xmlns:a="http://schemas.openxmlformats.org/drawingml/2006/main"/>
           <a:p xmlns:a="http://schemas.openxmlformats.org/drawingml/2006/main">
             <a:pPr algn="l">
+              <a:buNone/>
               <a:defRPr sz="1875" b="1">
                 <a:solidFill>
                   <a:srgbClr val="101828"/>
@@ -11208,6 +11375,7 @@
           <a:lstStyle xmlns:a="http://schemas.openxmlformats.org/drawingml/2006/main"/>
           <a:p xmlns:a="http://schemas.openxmlformats.org/drawingml/2006/main">
             <a:pPr algn="l">
+              <a:buNone/>
               <a:defRPr sz="1350" b="0">
                 <a:solidFill>
                   <a:srgbClr val="344054"/>
@@ -11260,6 +11428,7 @@
           <a:lstStyle xmlns:a="http://schemas.openxmlformats.org/drawingml/2006/main"/>
           <a:p xmlns:a="http://schemas.openxmlformats.org/drawingml/2006/main">
             <a:pPr algn="l">
+              <a:buNone/>
               <a:defRPr sz="1875" b="1">
                 <a:solidFill>
                   <a:srgbClr val="101828"/>
@@ -11312,6 +11481,7 @@
           <a:lstStyle xmlns:a="http://schemas.openxmlformats.org/drawingml/2006/main"/>
           <a:p xmlns:a="http://schemas.openxmlformats.org/drawingml/2006/main">
             <a:pPr algn="l">
+              <a:buNone/>
               <a:defRPr sz="1350" b="0">
                 <a:solidFill>
                   <a:srgbClr val="344054"/>
@@ -11364,6 +11534,7 @@
           <a:lstStyle xmlns:a="http://schemas.openxmlformats.org/drawingml/2006/main"/>
           <a:p xmlns:a="http://schemas.openxmlformats.org/drawingml/2006/main">
             <a:pPr algn="l">
+              <a:buNone/>
               <a:defRPr sz="1200" b="0">
                 <a:solidFill>
                   <a:srgbClr val="667085"/>

</xml_diff>